<commit_message>
docs: correct the deck statistics (656 backend tests, 28 merged pull requests)
</commit_message>
<xml_diff>
--- a/demo/StudAura-presentation.pptx
+++ b/demo/StudAura-presentation.pptx
@@ -2566,7 +2566,7 @@
                 <a:ea typeface="Calibri" pitchFamily="34" charset="-122"/>
                 <a:cs typeface="Calibri" pitchFamily="34" charset="-120"/>
               </a:rPr>
-              <a:t>371</a:t>
+              <a:t>656</a:t>
             </a:r>
             <a:endParaRPr lang="en-US" sz="5400" dirty="0"/>
           </a:p>
@@ -2605,7 +2605,7 @@
                 <a:ea typeface="Calibri" pitchFamily="34" charset="-122"/>
                 <a:cs typeface="Calibri" pitchFamily="34" charset="-120"/>
               </a:rPr>
-              <a:t>frontend unit tests</a:t>
+              <a:t>backend tests, real PostgreSQL</a:t>
             </a:r>
             <a:endParaRPr lang="en-US" sz="1400" dirty="0"/>
           </a:p>
@@ -2671,7 +2671,7 @@
                 <a:ea typeface="Calibri" pitchFamily="34" charset="-122"/>
                 <a:cs typeface="Calibri" pitchFamily="34" charset="-120"/>
               </a:rPr>
-              <a:t>35</a:t>
+              <a:t>371</a:t>
             </a:r>
             <a:endParaRPr lang="en-US" sz="5400" dirty="0"/>
           </a:p>
@@ -2710,7 +2710,7 @@
                 <a:ea typeface="Calibri" pitchFamily="34" charset="-122"/>
                 <a:cs typeface="Calibri" pitchFamily="34" charset="-120"/>
               </a:rPr>
-              <a:t>pull requests merged</a:t>
+              <a:t>frontend unit tests</a:t>
             </a:r>
             <a:endParaRPr lang="en-US" sz="1400" dirty="0"/>
           </a:p>
@@ -2776,7 +2776,7 @@
                 <a:ea typeface="Calibri" pitchFamily="34" charset="-122"/>
                 <a:cs typeface="Calibri" pitchFamily="34" charset="-120"/>
               </a:rPr>
-              <a:t>0</a:t>
+              <a:t>28</a:t>
             </a:r>
             <a:endParaRPr lang="en-US" sz="5400" dirty="0"/>
           </a:p>
@@ -2815,7 +2815,7 @@
                 <a:ea typeface="Calibri" pitchFamily="34" charset="-122"/>
                 <a:cs typeface="Calibri" pitchFamily="34" charset="-120"/>
               </a:rPr>
-              <a:t>fixable HIGH / CRITICAL findings</a:t>
+              <a:t>pull requests merged</a:t>
             </a:r>
             <a:endParaRPr lang="en-US" sz="1400" dirty="0"/>
           </a:p>
@@ -2841,6 +2841,27 @@
         <p:txBody>
           <a:bodyPr wrap="square" lIns="0" tIns="0" rIns="0" bIns="0" rtlCol="0" anchor="t"/>
           <a:lstStyle/>
+          <a:p>
+            <a:pPr marL="342900" indent="-342900">
+              <a:spcAft>
+                <a:spcPts val="600"/>
+              </a:spcAft>
+              <a:buSzPct val="100000"/>
+              <a:buChar char="•"/>
+            </a:pPr>
+            <a:r>
+              <a:rPr lang="en-US" sz="1600" dirty="0">
+                <a:solidFill>
+                  <a:srgbClr val="F5F5F5"/>
+                </a:solidFill>
+                <a:latin typeface="Calibri" pitchFamily="34" charset="0"/>
+                <a:ea typeface="Calibri" pitchFamily="34" charset="-122"/>
+                <a:cs typeface="Calibri" pitchFamily="34" charset="-120"/>
+              </a:rPr>
+              <a:t>Both images scan clean: zero fixable HIGH or CRITICAL findings</a:t>
+            </a:r>
+            <a:endParaRPr lang="en-US" sz="1600" dirty="0"/>
+          </a:p>
           <a:p>
             <a:pPr marL="342900" indent="-342900">
               <a:spcAft>

</xml_diff>

<commit_message>
docs: correct the deck statistics (#41)
Quality slide: 656 backend tests, 371 frontend tests, 28 merged pull requests, clean Trivy result.
</commit_message>
<xml_diff>
--- a/demo/StudAura-presentation.pptx
+++ b/demo/StudAura-presentation.pptx
@@ -2566,7 +2566,7 @@
                 <a:ea typeface="Calibri" pitchFamily="34" charset="-122"/>
                 <a:cs typeface="Calibri" pitchFamily="34" charset="-120"/>
               </a:rPr>
-              <a:t>371</a:t>
+              <a:t>656</a:t>
             </a:r>
             <a:endParaRPr lang="en-US" sz="5400" dirty="0"/>
           </a:p>
@@ -2605,7 +2605,7 @@
                 <a:ea typeface="Calibri" pitchFamily="34" charset="-122"/>
                 <a:cs typeface="Calibri" pitchFamily="34" charset="-120"/>
               </a:rPr>
-              <a:t>frontend unit tests</a:t>
+              <a:t>backend tests, real PostgreSQL</a:t>
             </a:r>
             <a:endParaRPr lang="en-US" sz="1400" dirty="0"/>
           </a:p>
@@ -2671,7 +2671,7 @@
                 <a:ea typeface="Calibri" pitchFamily="34" charset="-122"/>
                 <a:cs typeface="Calibri" pitchFamily="34" charset="-120"/>
               </a:rPr>
-              <a:t>35</a:t>
+              <a:t>371</a:t>
             </a:r>
             <a:endParaRPr lang="en-US" sz="5400" dirty="0"/>
           </a:p>
@@ -2710,7 +2710,7 @@
                 <a:ea typeface="Calibri" pitchFamily="34" charset="-122"/>
                 <a:cs typeface="Calibri" pitchFamily="34" charset="-120"/>
               </a:rPr>
-              <a:t>pull requests merged</a:t>
+              <a:t>frontend unit tests</a:t>
             </a:r>
             <a:endParaRPr lang="en-US" sz="1400" dirty="0"/>
           </a:p>
@@ -2776,7 +2776,7 @@
                 <a:ea typeface="Calibri" pitchFamily="34" charset="-122"/>
                 <a:cs typeface="Calibri" pitchFamily="34" charset="-120"/>
               </a:rPr>
-              <a:t>0</a:t>
+              <a:t>28</a:t>
             </a:r>
             <a:endParaRPr lang="en-US" sz="5400" dirty="0"/>
           </a:p>
@@ -2815,7 +2815,7 @@
                 <a:ea typeface="Calibri" pitchFamily="34" charset="-122"/>
                 <a:cs typeface="Calibri" pitchFamily="34" charset="-120"/>
               </a:rPr>
-              <a:t>fixable HIGH / CRITICAL findings</a:t>
+              <a:t>pull requests merged</a:t>
             </a:r>
             <a:endParaRPr lang="en-US" sz="1400" dirty="0"/>
           </a:p>
@@ -2841,6 +2841,27 @@
         <p:txBody>
           <a:bodyPr wrap="square" lIns="0" tIns="0" rIns="0" bIns="0" rtlCol="0" anchor="t"/>
           <a:lstStyle/>
+          <a:p>
+            <a:pPr marL="342900" indent="-342900">
+              <a:spcAft>
+                <a:spcPts val="600"/>
+              </a:spcAft>
+              <a:buSzPct val="100000"/>
+              <a:buChar char="•"/>
+            </a:pPr>
+            <a:r>
+              <a:rPr lang="en-US" sz="1600" dirty="0">
+                <a:solidFill>
+                  <a:srgbClr val="F5F5F5"/>
+                </a:solidFill>
+                <a:latin typeface="Calibri" pitchFamily="34" charset="0"/>
+                <a:ea typeface="Calibri" pitchFamily="34" charset="-122"/>
+                <a:cs typeface="Calibri" pitchFamily="34" charset="-120"/>
+              </a:rPr>
+              <a:t>Both images scan clean: zero fixable HIGH or CRITICAL findings</a:t>
+            </a:r>
+            <a:endParaRPr lang="en-US" sz="1600" dirty="0"/>
+          </a:p>
           <a:p>
             <a:pPr marL="342900" indent="-342900">
               <a:spcAft>

</xml_diff>